<commit_message>
Finish the Door 2 rename: presentation deck and autoscaling pages
Follow-on to 3cb8bff, which renamed Door 2 in the Start models but
left the deck and two prose references behind.

- presentation/content.js: cover phrases, the annotated-YAML
  callouts, the Door 2 card, slide id and eyebrow, and the
  "leaving is half of truth" lead. README arc updated to match.
- Regenerated index.html and k8s-for-developers.pptx from
  content.js; only the three affected slides changed.
- workloads/autoscaling.md and start/three-doors.md: drop the
  "Door 2 is honest" phrasing for what the door actually does.

Co-Authored-By: Claude Opus 5 (1M context) <noreply@anthropic.com>
</commit_message>
<xml_diff>
--- a/presentation/k8s-for-developers.pptx
+++ b/presentation/k8s-for-developers.pptx
@@ -1712,7 +1712,7 @@
                 <a:ea typeface="Calibri" pitchFamily="34" charset="-122"/>
                 <a:cs typeface="Calibri" pitchFamily="34" charset="-120"/>
               </a:rPr>
-              <a:t>   ·   truth</a:t>
+              <a:t>   ·   lifecycle</a:t>
             </a:r>
             <a:pPr indent="0" marL="0">
               <a:buNone/>
@@ -3468,7 +3468,7 @@
                 <a:ea typeface="Calibri" pitchFamily="34" charset="-122"/>
                 <a:cs typeface="Calibri" pitchFamily="34" charset="-120"/>
               </a:rPr>
-              <a:t>  ← 2 · Truth — leaving</a:t>
+              <a:t>  ← 2 · Lifecycle — leaving</a:t>
             </a:r>
             <a:endParaRPr lang="en-US" sz="750" dirty="0"/>
           </a:p>
@@ -3699,7 +3699,7 @@
                 <a:ea typeface="Calibri" pitchFamily="34" charset="-122"/>
                 <a:cs typeface="Calibri" pitchFamily="34" charset="-120"/>
               </a:rPr>
-              <a:t>  ← 2 · Truth — arriving</a:t>
+              <a:t>  ← 2 · Lifecycle — arriving</a:t>
             </a:r>
             <a:endParaRPr lang="en-US" sz="750" dirty="0"/>
           </a:p>
@@ -3776,7 +3776,7 @@
                 <a:ea typeface="Calibri" pitchFamily="34" charset="-122"/>
                 <a:cs typeface="Calibri" pitchFamily="34" charset="-120"/>
               </a:rPr>
-              <a:t>  ← 2 · Truth — the drain</a:t>
+              <a:t>  ← 2 · Lifecycle — the drain</a:t>
             </a:r>
             <a:endParaRPr lang="en-US" sz="750" dirty="0"/>
           </a:p>
@@ -4095,7 +4095,7 @@
                 <a:ea typeface="Calibri" pitchFamily="34" charset="-122"/>
                 <a:cs typeface="Calibri" pitchFamily="34" charset="-120"/>
               </a:rPr>
-              <a:t>Truth</a:t>
+              <a:t>Lifecycle</a:t>
             </a:r>
             <a:endParaRPr lang="en-US" sz="1250" dirty="0"/>
           </a:p>
@@ -4134,7 +4134,7 @@
                 <a:ea typeface="Calibri" pitchFamily="34" charset="-122"/>
                 <a:cs typeface="Calibri" pitchFamily="34" charset="-120"/>
               </a:rPr>
-              <a:t>Does it tell the truth about being ready — and about shutting down?</a:t>
+              <a:t>When should it get traffic, and when should it stop getting it?</a:t>
             </a:r>
             <a:endParaRPr lang="en-US" sz="950" dirty="0"/>
           </a:p>
@@ -5129,7 +5129,7 @@
                 <a:ea typeface="Calibri" pitchFamily="34" charset="-122"/>
                 <a:cs typeface="Calibri" pitchFamily="34" charset="-120"/>
               </a:rPr>
-              <a:t>DOOR 2 · TRUTH</a:t>
+              <a:t>DOOR 2 · LIFECYCLE</a:t>
             </a:r>
             <a:endParaRPr lang="en-US" sz="1000" dirty="0"/>
           </a:p>
@@ -5744,7 +5744,7 @@
                 <a:ea typeface="Calibri" pitchFamily="34" charset="-122"/>
                 <a:cs typeface="Calibri" pitchFamily="34" charset="-120"/>
               </a:rPr>
-              <a:t>And leaving is half of truth. When Kubernetes wants a pod gone, it removes the endpoint and sends SIGTERM at the same moment — these race. </a:t>
+              <a:t>And leaving is half the door. When Kubernetes wants a pod gone, it removes the endpoint and sends SIGTERM at the same moment — these race. </a:t>
             </a:r>
             <a:pPr indent="0" marL="0">
               <a:buNone/>

</xml_diff>